<commit_message>
feat: add arch diag drawio
</commit_message>
<xml_diff>
--- a/AS-ALD_CoScientist_Project.pptx
+++ b/AS-ALD_CoScientist_Project.pptx
@@ -10251,7 +10251,7 @@
                 <a:cs typeface="Calibri"/>
                 <a:sym typeface="Calibri"/>
               </a:rPr>
-              <a:t>The gate is the load-bearing rigor element — pathological surfaces are thrown out before any expensive reactivity call.</a:t>
+              <a:t>The gate is the load-bearing rigor element — pathological surfaces are thrown out before any expensive reactivity call. Two builder modes feed the same gate: fast procedural slabs, or an opt-in real MLIP melt-quench MD network (LLM auto-tuned).</a:t>
             </a:r>
             <a:endParaRPr/>
           </a:p>
@@ -14494,7 +14494,7 @@
                 <a:cs typeface="Calibri"/>
                 <a:sym typeface="Calibri"/>
               </a:rPr>
-              <a:t>From single test to a batch screening campaign</a:t>
+              <a:t>From a single test to a closed-loop batch screening campaign</a:t>
             </a:r>
             <a:endParaRPr/>
           </a:p>
@@ -15630,7 +15630,7 @@
                 <a:cs typeface="Calibri"/>
                 <a:sym typeface="Calibri"/>
               </a:rPr>
-              <a:t>Agent names the winner, runners-up, risks</a:t>
+              <a:t>Agent names winner, runners-up, risks; a failed campaign spawns a new AI-designed generation</a:t>
             </a:r>
             <a:endParaRPr/>
           </a:p>
@@ -19982,7 +19982,7 @@
                 <a:cs typeface="Calibri"/>
                 <a:sym typeface="Calibri"/>
               </a:rPr>
-              <a:t>Foundation-MLIP multi-site adsorption search</a:t>
+              <a:t>Foundation-MLIP (MACE / CHGNet) adsorption search</a:t>
             </a:r>
             <a:endParaRPr/>
           </a:p>
@@ -20021,7 +20021,7 @@
                 <a:cs typeface="Calibri"/>
                 <a:sym typeface="Calibri"/>
               </a:rPr>
-              <a:t>Reaction-energy endpoints on real surfaces</a:t>
+              <a:t>Reaction-energy endpoints · opt-in MLIP melt-quench slabs</a:t>
             </a:r>
             <a:endParaRPr/>
           </a:p>
@@ -30879,7 +30879,7 @@
                 <a:cs typeface="Calibri"/>
                 <a:sym typeface="Calibri"/>
               </a:rPr>
-              <a:t>Supervisor + Swarm</a:t>
+              <a:t>Supervisor + Swarm · ReAct designer</a:t>
             </a:r>
             <a:endParaRPr/>
           </a:p>
@@ -30918,7 +30918,7 @@
                 <a:cs typeface="Calibri"/>
                 <a:sym typeface="Calibri"/>
               </a:rPr>
-              <a:t>ReAct designer</a:t>
+              <a:t>Bounded Reflection loop</a:t>
             </a:r>
             <a:endParaRPr/>
           </a:p>
@@ -30957,7 +30957,7 @@
                 <a:cs typeface="Calibri"/>
                 <a:sym typeface="Calibri"/>
               </a:rPr>
-              <a:t>Reflection loop</a:t>
+              <a:t>AI planner · generational proposer · melt-quench tuner</a:t>
             </a:r>
             <a:endParaRPr/>
           </a:p>
@@ -31179,7 +31179,7 @@
                 <a:cs typeface="Calibri"/>
                 <a:sym typeface="Calibri"/>
               </a:rPr>
-              <a:t>ASE + foundation MLIP (MACE)</a:t>
+              <a:t>ASE + foundation MLIP (MACE / CHGNet)</a:t>
             </a:r>
             <a:endParaRPr/>
           </a:p>
@@ -31218,7 +31218,7 @@
                 <a:cs typeface="Calibri"/>
                 <a:sym typeface="Calibri"/>
               </a:rPr>
-              <a:t>rdkit molecules</a:t>
+              <a:t>rdkit molecules · pymatgen slabs</a:t>
             </a:r>
             <a:endParaRPr/>
           </a:p>
@@ -31257,7 +31257,7 @@
                 <a:cs typeface="Calibri"/>
                 <a:sym typeface="Calibri"/>
               </a:rPr>
-              <a:t>pymatgen slabs</a:t>
+              <a:t>Real MLIP melt-quench MD amorphization</a:t>
             </a:r>
             <a:endParaRPr/>
           </a:p>
@@ -31296,7 +31296,7 @@
                 <a:cs typeface="Calibri"/>
                 <a:sym typeface="Calibri"/>
               </a:rPr>
-              <a:t>xTB cross-check</a:t>
+              <a:t>xTB + D3 (torch-dftd) cross-check</a:t>
             </a:r>
             <a:endParaRPr/>
           </a:p>
@@ -31896,7 +31896,7 @@
                 <a:cs typeface="Calibri"/>
                 <a:sym typeface="Calibri"/>
               </a:rPr>
-              <a:t>Gradio web UI</a:t>
+              <a:t>Refresh-proof Gradio UI on Hugging Face</a:t>
             </a:r>
             <a:endParaRPr/>
           </a:p>
@@ -31974,7 +31974,7 @@
                 <a:cs typeface="Calibri"/>
                 <a:sym typeface="Calibri"/>
               </a:rPr>
-              <a:t>Docker + locked env</a:t>
+              <a:t>Docker + locked env · persistent storage</a:t>
             </a:r>
             <a:endParaRPr/>
           </a:p>

</xml_diff>